<commit_message>
fixed order and pivot and join
</commit_message>
<xml_diff>
--- a/docs/content/final_project/final_project_lecture.pptx
+++ b/docs/content/final_project/final_project_lecture.pptx
@@ -3296,7 +3296,7 @@
             </a:pPr>
             <a:r>
               <a:rPr/>
-              <a:t>Lecture 15 — Your Final Project Starts Now</a:t>
+              <a:t>Lecture 13 — Your Final Project Starts Now</a:t>
             </a:r>
           </a:p>
         </p:txBody>
@@ -3357,7 +3357,7 @@
             </a:pPr>
             <a:r>
               <a:rPr/>
-              <a:t>2026-10-09</a:t>
+              <a:t>2026-10-19</a:t>
             </a:r>
           </a:p>
         </p:txBody>

</xml_diff>